<commit_message>
Banner: a Follow us code for Instagram beside the review code
Adds oberrieden.pub/instagram, a noindex redirect to the pub's Instagram
built like /review, so the printed code survives a change of handle. The
sitemap skips it as it skips /review.

Both codes are 42mm, down from one at 50mm: two at 50mm leave the text
138mm, narrower than the 143mm German joke line. The address moves down to
sit level with the tops of the codes, and each ask breaks at its sentence.
The deck carries the same two codes and now regenerates both PNGs itself.

Co-Authored-By: Claude Opus 5.5 <noreply@anthropic.com>
</commit_message>
<xml_diff>
--- a/print/banner.pptx
+++ b/print/banner.pptx
@@ -508,7 +508,7 @@
           <a:p/>
           <a:p>
             <a:r>
-              <a:t>The QR code points at oberrieden.pub/review, which redirects to the pub's Google listing. If that Google link ever changes, the redirect is what changes - this code stays valid, so printed copies keep working.</a:t>
+              <a:t>The left code points at oberrieden.pub/review, which redirects to the pub's Google listing; the right one at oberrieden.pub/instagram. If either link ever changes, the redirect is what changes - the codes stay valid, so printed copies keep working.</a:t>
             </a:r>
           </a:p>
           <a:p/>
@@ -3658,7 +3658,7 @@
         <p:spPr>
           <a:xfrm>
             <a:off x="792000" y="1152000"/>
-            <a:ext cx="7092000" cy="720000"/>
+            <a:ext cx="5652000" cy="720000"/>
           </a:xfrm>
           <a:prstGeom prst="rect">
             <a:avLst/>
@@ -3693,7 +3693,7 @@
         <p:spPr>
           <a:xfrm>
             <a:off x="792000" y="1926000"/>
-            <a:ext cx="7092000" cy="288000"/>
+            <a:ext cx="5652000" cy="288000"/>
           </a:xfrm>
           <a:prstGeom prst="rect">
             <a:avLst/>
@@ -3728,7 +3728,7 @@
         <p:spPr>
           <a:xfrm>
             <a:off x="792000" y="2268000"/>
-            <a:ext cx="7092000" cy="252000"/>
+            <a:ext cx="5652000" cy="468000"/>
           </a:xfrm>
           <a:prstGeom prst="rect">
             <a:avLst/>
@@ -3749,7 +3749,17 @@
                 </a:solidFill>
                 <a:latin typeface="Calibri"/>
               </a:rPr>
-              <a:t>Hat es Ihnen gefallen? Sagen Sie es Google. Wenn nicht, dem Wirt.</a:t>
+              <a:t>Hat es Ihnen gefallen? Sagen Sie es Google.</a:t>
+            </a:r>
+            <a:br/>
+            <a:r>
+              <a:rPr sz="1400" b="0">
+                <a:solidFill>
+                  <a:srgbClr val="531C23"/>
+                </a:solidFill>
+                <a:latin typeface="Calibri"/>
+              </a:rPr>
+              <a:t>Wenn nicht, dem Wirt.</a:t>
             </a:r>
           </a:p>
         </p:txBody>
@@ -3770,8 +3780,8 @@
         </p:blipFill>
         <p:spPr>
           <a:xfrm>
-            <a:off x="8100000" y="1134000"/>
-            <a:ext cx="1800000" cy="1800000"/>
+            <a:off x="6660000" y="1188000"/>
+            <a:ext cx="1512000" cy="1512000"/>
           </a:xfrm>
           <a:prstGeom prst="rect">
             <a:avLst/>
@@ -3786,8 +3796,8 @@
         </p:nvSpPr>
         <p:spPr>
           <a:xfrm>
-            <a:off x="7812000" y="2988000"/>
-            <a:ext cx="2376000" cy="216000"/>
+            <a:off x="6552000" y="2772000"/>
+            <a:ext cx="1728000" cy="216000"/>
           </a:xfrm>
           <a:prstGeom prst="rect">
             <a:avLst/>
@@ -3813,9 +3823,68 @@
           </a:p>
         </p:txBody>
       </p:sp>
-      <p:sp>
-        <p:nvSpPr>
-          <p:cNvPr id="10" name="Rectangle 9"/>
+      <p:pic>
+        <p:nvPicPr>
+          <p:cNvPr id="10" name="Picture 9" descr="qr-instagram.png"/>
+          <p:cNvPicPr>
+            <a:picLocks noChangeAspect="1"/>
+          </p:cNvPicPr>
+          <p:nvPr/>
+        </p:nvPicPr>
+        <p:blipFill>
+          <a:blip r:embed="rId3"/>
+          <a:stretch>
+            <a:fillRect/>
+          </a:stretch>
+        </p:blipFill>
+        <p:spPr>
+          <a:xfrm>
+            <a:off x="8388000" y="1188000"/>
+            <a:ext cx="1512000" cy="1512000"/>
+          </a:xfrm>
+          <a:prstGeom prst="rect">
+            <a:avLst/>
+          </a:prstGeom>
+        </p:spPr>
+      </p:pic>
+      <p:sp>
+        <p:nvSpPr>
+          <p:cNvPr id="11" name="TextBox 10"/>
+          <p:cNvSpPr txBox="1"/>
+          <p:nvPr/>
+        </p:nvSpPr>
+        <p:spPr>
+          <a:xfrm>
+            <a:off x="8280000" y="2772000"/>
+            <a:ext cx="1728000" cy="216000"/>
+          </a:xfrm>
+          <a:prstGeom prst="rect">
+            <a:avLst/>
+          </a:prstGeom>
+          <a:noFill/>
+        </p:spPr>
+        <p:txBody>
+          <a:bodyPr wrap="square" anchor="t" lIns="0" rIns="0" tIns="0" bIns="0">
+            <a:spAutoFit/>
+          </a:bodyPr>
+          <a:lstStyle/>
+          <a:p>
+            <a:pPr algn="ctr"/>
+            <a:r>
+              <a:rPr sz="1000" b="1" spc="150">
+                <a:solidFill>
+                  <a:srgbClr val="531C23"/>
+                </a:solidFill>
+                <a:latin typeface="Trebuchet MS"/>
+              </a:rPr>
+              <a:t>FOLGEN SIE UNS</a:t>
+            </a:r>
+          </a:p>
+        </p:txBody>
+      </p:sp>
+      <p:sp>
+        <p:nvSpPr>
+          <p:cNvPr id="12" name="Rectangle 11"/>
           <p:cNvSpPr/>
           <p:nvPr/>
         </p:nvSpPr>
@@ -3859,7 +3928,7 @@
       </p:sp>
       <p:sp>
         <p:nvSpPr>
-          <p:cNvPr id="11" name="Rectangle 10"/>
+          <p:cNvPr id="13" name="Rectangle 12"/>
           <p:cNvSpPr/>
           <p:nvPr/>
         </p:nvSpPr>
@@ -3901,7 +3970,7 @@
       </p:sp>
       <p:sp>
         <p:nvSpPr>
-          <p:cNvPr id="12" name="TextBox 11"/>
+          <p:cNvPr id="14" name="TextBox 13"/>
           <p:cNvSpPr txBox="1"/>
           <p:nvPr/>
         </p:nvSpPr>
@@ -3936,14 +4005,14 @@
       </p:sp>
       <p:sp>
         <p:nvSpPr>
-          <p:cNvPr id="13" name="TextBox 12"/>
+          <p:cNvPr id="15" name="TextBox 14"/>
           <p:cNvSpPr txBox="1"/>
           <p:nvPr/>
         </p:nvSpPr>
         <p:spPr>
           <a:xfrm>
             <a:off x="792000" y="4824000"/>
-            <a:ext cx="7092000" cy="720000"/>
+            <a:ext cx="5652000" cy="720000"/>
           </a:xfrm>
           <a:prstGeom prst="rect">
             <a:avLst/>
@@ -3971,14 +4040,14 @@
       </p:sp>
       <p:sp>
         <p:nvSpPr>
-          <p:cNvPr id="14" name="TextBox 13"/>
+          <p:cNvPr id="16" name="TextBox 15"/>
           <p:cNvSpPr txBox="1"/>
           <p:nvPr/>
         </p:nvSpPr>
         <p:spPr>
           <a:xfrm>
             <a:off x="792000" y="5598000"/>
-            <a:ext cx="7092000" cy="288000"/>
+            <a:ext cx="5652000" cy="288000"/>
           </a:xfrm>
           <a:prstGeom prst="rect">
             <a:avLst/>
@@ -4006,14 +4075,14 @@
       </p:sp>
       <p:sp>
         <p:nvSpPr>
-          <p:cNvPr id="15" name="TextBox 14"/>
+          <p:cNvPr id="17" name="TextBox 16"/>
           <p:cNvSpPr txBox="1"/>
           <p:nvPr/>
         </p:nvSpPr>
         <p:spPr>
           <a:xfrm>
             <a:off x="792000" y="5940000"/>
-            <a:ext cx="7092000" cy="252000"/>
+            <a:ext cx="5652000" cy="468000"/>
           </a:xfrm>
           <a:prstGeom prst="rect">
             <a:avLst/>
@@ -4034,14 +4103,24 @@
                 </a:solidFill>
                 <a:latin typeface="Calibri"/>
               </a:rPr>
-              <a:t>Enjoyed it? Tell Google. If not, tell the landlord.</a:t>
+              <a:t>Enjoyed it? Tell Google.</a:t>
+            </a:r>
+            <a:br/>
+            <a:r>
+              <a:rPr sz="1400" b="0">
+                <a:solidFill>
+                  <a:srgbClr val="531C23"/>
+                </a:solidFill>
+                <a:latin typeface="Calibri"/>
+              </a:rPr>
+              <a:t>If not, tell the landlord.</a:t>
             </a:r>
           </a:p>
         </p:txBody>
       </p:sp>
       <p:pic>
         <p:nvPicPr>
-          <p:cNvPr id="16" name="Picture 15" descr="qr-review.png"/>
+          <p:cNvPr id="18" name="Picture 17" descr="qr-review.png"/>
           <p:cNvPicPr>
             <a:picLocks noChangeAspect="1"/>
           </p:cNvPicPr>
@@ -4055,8 +4134,8 @@
         </p:blipFill>
         <p:spPr>
           <a:xfrm>
-            <a:off x="8100000" y="4806000"/>
-            <a:ext cx="1800000" cy="1800000"/>
+            <a:off x="6660000" y="4860000"/>
+            <a:ext cx="1512000" cy="1512000"/>
           </a:xfrm>
           <a:prstGeom prst="rect">
             <a:avLst/>
@@ -4065,14 +4144,14 @@
       </p:pic>
       <p:sp>
         <p:nvSpPr>
-          <p:cNvPr id="17" name="TextBox 16"/>
+          <p:cNvPr id="19" name="TextBox 18"/>
           <p:cNvSpPr txBox="1"/>
           <p:nvPr/>
         </p:nvSpPr>
         <p:spPr>
           <a:xfrm>
-            <a:off x="7812000" y="6660000"/>
-            <a:ext cx="2376000" cy="216000"/>
+            <a:off x="6552000" y="6444000"/>
+            <a:ext cx="1728000" cy="216000"/>
           </a:xfrm>
           <a:prstGeom prst="rect">
             <a:avLst/>
@@ -4098,9 +4177,68 @@
           </a:p>
         </p:txBody>
       </p:sp>
+      <p:pic>
+        <p:nvPicPr>
+          <p:cNvPr id="20" name="Picture 19" descr="qr-instagram.png"/>
+          <p:cNvPicPr>
+            <a:picLocks noChangeAspect="1"/>
+          </p:cNvPicPr>
+          <p:nvPr/>
+        </p:nvPicPr>
+        <p:blipFill>
+          <a:blip r:embed="rId3"/>
+          <a:stretch>
+            <a:fillRect/>
+          </a:stretch>
+        </p:blipFill>
+        <p:spPr>
+          <a:xfrm>
+            <a:off x="8388000" y="4860000"/>
+            <a:ext cx="1512000" cy="1512000"/>
+          </a:xfrm>
+          <a:prstGeom prst="rect">
+            <a:avLst/>
+          </a:prstGeom>
+        </p:spPr>
+      </p:pic>
+      <p:sp>
+        <p:nvSpPr>
+          <p:cNvPr id="21" name="TextBox 20"/>
+          <p:cNvSpPr txBox="1"/>
+          <p:nvPr/>
+        </p:nvSpPr>
+        <p:spPr>
+          <a:xfrm>
+            <a:off x="8280000" y="6444000"/>
+            <a:ext cx="1728000" cy="216000"/>
+          </a:xfrm>
+          <a:prstGeom prst="rect">
+            <a:avLst/>
+          </a:prstGeom>
+          <a:noFill/>
+        </p:spPr>
+        <p:txBody>
+          <a:bodyPr wrap="square" anchor="t" lIns="0" rIns="0" tIns="0" bIns="0">
+            <a:spAutoFit/>
+          </a:bodyPr>
+          <a:lstStyle/>
+          <a:p>
+            <a:pPr algn="ctr"/>
+            <a:r>
+              <a:rPr sz="1000" b="1" spc="150">
+                <a:solidFill>
+                  <a:srgbClr val="531C23"/>
+                </a:solidFill>
+                <a:latin typeface="Trebuchet MS"/>
+              </a:rPr>
+              <a:t>FOLLOW US</a:t>
+            </a:r>
+          </a:p>
+        </p:txBody>
+      </p:sp>
       <p:cxnSp>
         <p:nvCxnSpPr>
-          <p:cNvPr id="18" name="Connector 17"/>
+          <p:cNvPr id="22" name="Connector 21"/>
           <p:cNvCxnSpPr/>
           <p:nvPr/>
         </p:nvCxnSpPr>

</xml_diff>